<commit_message>
Improve offline relay and specialist-aware matching
</commit_message>
<xml_diff>
--- a/ReadyRoute_presentation.pptx
+++ b/ReadyRoute_presentation.pptx
@@ -2,18 +2,18 @@
 <file path=ppt/presentation.xml><?xml version="1.0" encoding="utf-8"?>
 <p:presentation xmlns:p="http://schemas.openxmlformats.org/presentationml/2006/main">
   <p:sldMasterIdLst>
-    <p:sldMasterId xmlns:r="http://schemas.openxmlformats.org/officeDocument/2006/relationships" id="2147483648" r:id="R69f5bef061504668"/>
+    <p:sldMasterId xmlns:r="http://schemas.openxmlformats.org/officeDocument/2006/relationships" id="2147483648" r:id="R82f57a84c9924944"/>
   </p:sldMasterIdLst>
   <p:notesMasterIdLst>
-    <p:notesMasterId xmlns:r="http://schemas.openxmlformats.org/officeDocument/2006/relationships" r:id="R5aa20784d12a4fb1"/>
+    <p:notesMasterId xmlns:r="http://schemas.openxmlformats.org/officeDocument/2006/relationships" r:id="R43c7bc1ccdd942d4"/>
   </p:notesMasterIdLst>
   <p:sldIdLst>
-    <p:sldId xmlns:r="http://schemas.openxmlformats.org/officeDocument/2006/relationships" id="256" r:id="Rbfd5a2bf180c4002"/>
-    <p:sldId xmlns:r="http://schemas.openxmlformats.org/officeDocument/2006/relationships" id="257" r:id="R2005116df4424ffa"/>
-    <p:sldId xmlns:r="http://schemas.openxmlformats.org/officeDocument/2006/relationships" id="258" r:id="Rc9966abfb16f489d"/>
-    <p:sldId xmlns:r="http://schemas.openxmlformats.org/officeDocument/2006/relationships" id="259" r:id="R86f990597fc14dd7"/>
-    <p:sldId xmlns:r="http://schemas.openxmlformats.org/officeDocument/2006/relationships" id="260" r:id="R556eda9c365c4ad8"/>
-    <p:sldId xmlns:r="http://schemas.openxmlformats.org/officeDocument/2006/relationships" id="261" r:id="R43583c1742944e7d"/>
+    <p:sldId xmlns:r="http://schemas.openxmlformats.org/officeDocument/2006/relationships" id="256" r:id="Ra3d60ca3a5714197"/>
+    <p:sldId xmlns:r="http://schemas.openxmlformats.org/officeDocument/2006/relationships" id="257" r:id="R373606511c074889"/>
+    <p:sldId xmlns:r="http://schemas.openxmlformats.org/officeDocument/2006/relationships" id="258" r:id="Rba47863401954ab8"/>
+    <p:sldId xmlns:r="http://schemas.openxmlformats.org/officeDocument/2006/relationships" id="259" r:id="Ree61d07e88b641c9"/>
+    <p:sldId xmlns:r="http://schemas.openxmlformats.org/officeDocument/2006/relationships" id="260" r:id="R6123af9dfc194c9a"/>
+    <p:sldId xmlns:r="http://schemas.openxmlformats.org/officeDocument/2006/relationships" id="261" r:id="Re79a702f84ca42fa"/>
   </p:sldIdLst>
   <p:sldSz cx="12192000" cy="6858000"/>
   <p:notesSz cx="6858000" cy="9144000"/>
@@ -587,7 +587,7 @@
           <a:lstStyle xmlns:a="http://schemas.openxmlformats.org/drawingml/2006/main"/>
           <a:p xmlns:a="http://schemas.openxmlformats.org/drawingml/2006/main">
             <a:r>
-              <a:t>The three views are implemented in a single HTML file. In this educational demo, plan and request data remain in browser local storage. There is no account, server, alert feed, or dispatch integration.</a:t>
+              <a:t>The three views are implemented in a single HTML file. A request can be carried manually to another device as a compact code with a typo check. The code contains a location and is not encrypted. There is no account, server, alert feed, automatic sync, or dispatch integration.</a:t>
             </a:r>
           </a:p>
         </p:txBody>
@@ -727,7 +727,7 @@
           <a:lstStyle xmlns:a="http://schemas.openxmlformats.org/drawingml/2006/main"/>
           <a:p xmlns:a="http://schemas.openxmlformats.org/drawingml/2006/main">
             <a:r>
-              <a:t>The Pine Avenue example is a fictional request. It is scored 30 for immediate urgency, 10 for medical need, and 6 for a power-related access barrier. The resource matcher checks category, access needs, and remaining capacity; the suggested medical backup-power team has one available slot. The North library example scores 26. Waiting time can add points, so scores in the live app may change. This formula is illustrative, unvalidated, and never dispatches help automatically.</a:t>
+              <a:t>The Pine Avenue example is fictional. It scores 30 for immediate urgency, 10 for medical need, and 6 for a power access barrier. The planner reserves available slots across the queue and uses a general team before a specialist when possible. It suggests the backup-power team here. The North library example scores 26. Waiting can add points, so live scores can change. This formula is illustrative, unvalidated, and never dispatches help automatically.</a:t>
             </a:r>
           </a:p>
         </p:txBody>
@@ -797,7 +797,7 @@
           <a:lstStyle xmlns:a="http://schemas.openxmlformats.org/drawingml/2006/main"/>
           <a:p xmlns:a="http://schemas.openxmlformats.org/drawingml/2006/main">
             <a:r>
-              <a:t>This project has no measured real-world impact. It could help speed intake, make prioritization clearer, and surface barriers. A pilot should measure intake time, resource match coverage, and accessible completion. Real deployment needs official sources, secure synchronization, consent, multilingual and accessibility testing, and trained emergency-management partners. The concept relates to SDG 11 and SDG 13.</a:t>
+              <a:t>This project has no measured real-world impact. Manual relay may help where devices cannot sync, but depends on trusted handoff and is not encrypted. A pilot should measure intake time, match coverage, relay success, and accessible completion. Real deployment needs official sources, secure synchronization, consent, multilingual and accessibility testing, and trained emergency-management partners. The concept relates to SDG 11 and SDG 13.</a:t>
             </a:r>
           </a:p>
         </p:txBody>
@@ -865,7 +865,7 @@
   </p:cSld>
   <p:clrMap bg1="lt1" tx1="dk1" bg2="lt2" tx2="dk2" accent1="accent1" accent2="accent2" accent3="accent3" accent4="accent4" accent5="accent5" accent6="accent6" hlink="hlink" folHlink="folHlink"/>
   <p:sldLayoutIdLst>
-    <p:sldLayoutId xmlns:r="http://schemas.openxmlformats.org/officeDocument/2006/relationships" id="2147483649" r:id="R8acd277795304052"/>
+    <p:sldLayoutId xmlns:r="http://schemas.openxmlformats.org/officeDocument/2006/relationships" id="2147483649" r:id="Rea3f6ca8374d4774"/>
   </p:sldLayoutIdLst>
   <p:txStyles>
     <p:titleStyle>
@@ -1420,7 +1420,7 @@
           <p:nvPr/>
         </p:nvPicPr>
         <p:blipFill>
-          <a:blip xmlns:r="http://schemas.openxmlformats.org/officeDocument/2006/relationships" xmlns:a="http://schemas.openxmlformats.org/drawingml/2006/main" r:embed="Re55ed1582ede495b"/>
+          <a:blip xmlns:r="http://schemas.openxmlformats.org/officeDocument/2006/relationships" xmlns:a="http://schemas.openxmlformats.org/drawingml/2006/main" r:embed="Re6bebae11d654cbd"/>
           <a:srcRect xmlns:a="http://schemas.openxmlformats.org/drawingml/2006/main" l="0" t="27" r="0" b="27"/>
           <a:stretch xmlns:a="http://schemas.openxmlformats.org/drawingml/2006/main">
             <a:fillRect l="0" t="0" r="0" b="0"/>
@@ -1441,7 +1441,7 @@
           <p:cNvPr id="2" name="">
             <a:extLst xmlns:a="http://schemas.openxmlformats.org/drawingml/2006/main">
               <a:ext uri="{FF2B5EF4-FFF2-40B4-BE49-F238E27FC236}">
-                <a16:creationId xmlns:a16="http://schemas.microsoft.com/office/drawing/2014/main" id="{8F165886-CC7D-4472-B585-B45D06B39EB7}"/>
+                <a16:creationId xmlns:a16="http://schemas.microsoft.com/office/drawing/2014/main" id="{68B50236-F2A9-4350-9F55-2B92C4FFB3C2}"/>
               </a:ext>
             </a:extLst>
           </p:cNvPr>
@@ -1498,7 +1498,7 @@
           <p:cNvPr id="3" name="">
             <a:extLst xmlns:a="http://schemas.openxmlformats.org/drawingml/2006/main">
               <a:ext uri="{FF2B5EF4-FFF2-40B4-BE49-F238E27FC236}">
-                <a16:creationId xmlns:a16="http://schemas.microsoft.com/office/drawing/2014/main" id="{8442A125-49D0-4E52-8023-DA8603B39017}"/>
+                <a16:creationId xmlns:a16="http://schemas.microsoft.com/office/drawing/2014/main" id="{00EA9EE7-5D1C-455D-A76B-5AFACC6875C3}"/>
               </a:ext>
             </a:extLst>
           </p:cNvPr>
@@ -1578,7 +1578,7 @@
           <p:cNvPr id="4" name="">
             <a:extLst xmlns:a="http://schemas.openxmlformats.org/drawingml/2006/main">
               <a:ext uri="{FF2B5EF4-FFF2-40B4-BE49-F238E27FC236}">
-                <a16:creationId xmlns:a16="http://schemas.microsoft.com/office/drawing/2014/main" id="{372FAAFC-8C9C-4D05-82DA-C4A7C4B69540}"/>
+                <a16:creationId xmlns:a16="http://schemas.microsoft.com/office/drawing/2014/main" id="{48E2A84E-6E0E-459A-BDDD-951FFF549FA1}"/>
               </a:ext>
             </a:extLst>
           </p:cNvPr>
@@ -1608,7 +1608,7 @@
           <p:cNvPr id="5" name="">
             <a:extLst xmlns:a="http://schemas.openxmlformats.org/drawingml/2006/main">
               <a:ext uri="{FF2B5EF4-FFF2-40B4-BE49-F238E27FC236}">
-                <a16:creationId xmlns:a16="http://schemas.microsoft.com/office/drawing/2014/main" id="{D554E695-6886-4B2B-8413-F7CD145E10EF}"/>
+                <a16:creationId xmlns:a16="http://schemas.microsoft.com/office/drawing/2014/main" id="{0363DA89-37B5-445D-9E4C-18596F3DF694}"/>
               </a:ext>
             </a:extLst>
           </p:cNvPr>
@@ -1665,7 +1665,7 @@
           <p:cNvPr id="6" name="">
             <a:extLst xmlns:a="http://schemas.openxmlformats.org/drawingml/2006/main">
               <a:ext uri="{FF2B5EF4-FFF2-40B4-BE49-F238E27FC236}">
-                <a16:creationId xmlns:a16="http://schemas.microsoft.com/office/drawing/2014/main" id="{C6616F35-03B7-4A05-975C-DEC020F20AE2}"/>
+                <a16:creationId xmlns:a16="http://schemas.microsoft.com/office/drawing/2014/main" id="{2BA3C5D6-FD4E-499D-BC7E-197D34FC685C}"/>
               </a:ext>
             </a:extLst>
           </p:cNvPr>
@@ -1720,7 +1720,7 @@
     </p:spTree>
     <p:extLst>
       <p:ext uri="{BB962C8B-B14F-4D97-AF65-F5344CB8AC3E}">
-        <p14:creationId xmlns:p14="http://schemas.microsoft.com/office/powerpoint/2010/main" val="1492687315"/>
+        <p14:creationId xmlns:p14="http://schemas.microsoft.com/office/powerpoint/2010/main" val="59142238"/>
       </p:ext>
     </p:extLst>
   </p:cSld>
@@ -1751,7 +1751,7 @@
           <p:cNvPr id="13" name="">
             <a:extLst xmlns:a="http://schemas.openxmlformats.org/drawingml/2006/main">
               <a:ext uri="{FF2B5EF4-FFF2-40B4-BE49-F238E27FC236}">
-                <a16:creationId xmlns:a16="http://schemas.microsoft.com/office/drawing/2014/main" id="{8793A6F4-CB30-4963-BB59-8C158B2A3DEB}"/>
+                <a16:creationId xmlns:a16="http://schemas.microsoft.com/office/drawing/2014/main" id="{7E27D40B-B582-4AF8-8BFF-EC449D5BAD6F}"/>
               </a:ext>
             </a:extLst>
           </p:cNvPr>
@@ -1808,7 +1808,7 @@
           <p:cNvPr id="2" name="">
             <a:extLst xmlns:a="http://schemas.openxmlformats.org/drawingml/2006/main">
               <a:ext uri="{FF2B5EF4-FFF2-40B4-BE49-F238E27FC236}">
-                <a16:creationId xmlns:a16="http://schemas.microsoft.com/office/drawing/2014/main" id="{77469C2F-9BC3-4218-933B-1A3004710D37}"/>
+                <a16:creationId xmlns:a16="http://schemas.microsoft.com/office/drawing/2014/main" id="{076BB933-FB56-4A10-B4F4-B4A5F019FE0B}"/>
               </a:ext>
             </a:extLst>
           </p:cNvPr>
@@ -1865,7 +1865,7 @@
           <p:cNvPr id="3" name="">
             <a:extLst xmlns:a="http://schemas.openxmlformats.org/drawingml/2006/main">
               <a:ext uri="{FF2B5EF4-FFF2-40B4-BE49-F238E27FC236}">
-                <a16:creationId xmlns:a16="http://schemas.microsoft.com/office/drawing/2014/main" id="{E8DC0AE3-9B76-4182-B74D-234148D1F67E}"/>
+                <a16:creationId xmlns:a16="http://schemas.microsoft.com/office/drawing/2014/main" id="{B2326B24-1212-4101-A498-49ACF50B18CD}"/>
               </a:ext>
             </a:extLst>
           </p:cNvPr>
@@ -1895,7 +1895,7 @@
           <p:cNvPr id="4" name="">
             <a:extLst xmlns:a="http://schemas.openxmlformats.org/drawingml/2006/main">
               <a:ext uri="{FF2B5EF4-FFF2-40B4-BE49-F238E27FC236}">
-                <a16:creationId xmlns:a16="http://schemas.microsoft.com/office/drawing/2014/main" id="{AB1E1F1F-7909-4124-BD2B-E2A566501272}"/>
+                <a16:creationId xmlns:a16="http://schemas.microsoft.com/office/drawing/2014/main" id="{215EDFCC-7983-45EA-8826-AFD00701C3C1}"/>
               </a:ext>
             </a:extLst>
           </p:cNvPr>
@@ -1952,7 +1952,7 @@
           <p:cNvPr id="5" name="">
             <a:extLst xmlns:a="http://schemas.openxmlformats.org/drawingml/2006/main">
               <a:ext uri="{FF2B5EF4-FFF2-40B4-BE49-F238E27FC236}">
-                <a16:creationId xmlns:a16="http://schemas.microsoft.com/office/drawing/2014/main" id="{18C11C23-AD61-43B1-9904-52F732A6C065}"/>
+                <a16:creationId xmlns:a16="http://schemas.microsoft.com/office/drawing/2014/main" id="{23E5DDC8-08AB-4078-B984-74DE5F3DA368}"/>
               </a:ext>
             </a:extLst>
           </p:cNvPr>
@@ -2009,7 +2009,7 @@
           <p:cNvPr id="6" name="">
             <a:extLst xmlns:a="http://schemas.openxmlformats.org/drawingml/2006/main">
               <a:ext uri="{FF2B5EF4-FFF2-40B4-BE49-F238E27FC236}">
-                <a16:creationId xmlns:a16="http://schemas.microsoft.com/office/drawing/2014/main" id="{EA9CD360-EA13-475A-9152-1B291868ECF9}"/>
+                <a16:creationId xmlns:a16="http://schemas.microsoft.com/office/drawing/2014/main" id="{8993551A-A1F8-45E8-8EF0-AF446C9FC3EB}"/>
               </a:ext>
             </a:extLst>
           </p:cNvPr>
@@ -2066,7 +2066,7 @@
           <p:cNvPr id="7" name="">
             <a:extLst xmlns:a="http://schemas.openxmlformats.org/drawingml/2006/main">
               <a:ext uri="{FF2B5EF4-FFF2-40B4-BE49-F238E27FC236}">
-                <a16:creationId xmlns:a16="http://schemas.microsoft.com/office/drawing/2014/main" id="{F5E73173-D14A-4F78-842A-BF475B12AF46}"/>
+                <a16:creationId xmlns:a16="http://schemas.microsoft.com/office/drawing/2014/main" id="{29954172-97F7-45DC-9E18-A4B0A2531ED5}"/>
               </a:ext>
             </a:extLst>
           </p:cNvPr>
@@ -2096,7 +2096,7 @@
           <p:cNvPr id="8" name="">
             <a:extLst xmlns:a="http://schemas.openxmlformats.org/drawingml/2006/main">
               <a:ext uri="{FF2B5EF4-FFF2-40B4-BE49-F238E27FC236}">
-                <a16:creationId xmlns:a16="http://schemas.microsoft.com/office/drawing/2014/main" id="{AEB35368-B678-43F9-9413-D5992916B6A1}"/>
+                <a16:creationId xmlns:a16="http://schemas.microsoft.com/office/drawing/2014/main" id="{D648E6F9-9FCB-4754-8952-45216AC34CE7}"/>
               </a:ext>
             </a:extLst>
           </p:cNvPr>
@@ -2153,7 +2153,7 @@
           <p:cNvPr id="9" name="">
             <a:extLst xmlns:a="http://schemas.openxmlformats.org/drawingml/2006/main">
               <a:ext uri="{FF2B5EF4-FFF2-40B4-BE49-F238E27FC236}">
-                <a16:creationId xmlns:a16="http://schemas.microsoft.com/office/drawing/2014/main" id="{68ED2CE4-419E-488F-B42D-1F72B6EA666B}"/>
+                <a16:creationId xmlns:a16="http://schemas.microsoft.com/office/drawing/2014/main" id="{5A743209-4C37-4E8F-B08C-090012699EA8}"/>
               </a:ext>
             </a:extLst>
           </p:cNvPr>
@@ -2210,7 +2210,7 @@
           <p:cNvPr id="10" name="">
             <a:extLst xmlns:a="http://schemas.openxmlformats.org/drawingml/2006/main">
               <a:ext uri="{FF2B5EF4-FFF2-40B4-BE49-F238E27FC236}">
-                <a16:creationId xmlns:a16="http://schemas.microsoft.com/office/drawing/2014/main" id="{C2BD8FE3-9D7B-48A3-9BE5-C4070BBA48B5}"/>
+                <a16:creationId xmlns:a16="http://schemas.microsoft.com/office/drawing/2014/main" id="{835A6CF4-1396-4BE9-A0C4-D15A1B08E633}"/>
               </a:ext>
             </a:extLst>
           </p:cNvPr>
@@ -2240,7 +2240,7 @@
           <p:cNvPr id="11" name="">
             <a:extLst xmlns:a="http://schemas.openxmlformats.org/drawingml/2006/main">
               <a:ext uri="{FF2B5EF4-FFF2-40B4-BE49-F238E27FC236}">
-                <a16:creationId xmlns:a16="http://schemas.microsoft.com/office/drawing/2014/main" id="{52E91679-9DEF-4224-9BEA-B45592BDD643}"/>
+                <a16:creationId xmlns:a16="http://schemas.microsoft.com/office/drawing/2014/main" id="{CCCB3440-AB65-40E3-8A6D-7C4689315B2F}"/>
               </a:ext>
             </a:extLst>
           </p:cNvPr>
@@ -2297,7 +2297,7 @@
           <p:cNvPr id="12" name="">
             <a:extLst xmlns:a="http://schemas.openxmlformats.org/drawingml/2006/main">
               <a:ext uri="{FF2B5EF4-FFF2-40B4-BE49-F238E27FC236}">
-                <a16:creationId xmlns:a16="http://schemas.microsoft.com/office/drawing/2014/main" id="{AB4E6AEF-1320-462B-9884-189BB5F4D781}"/>
+                <a16:creationId xmlns:a16="http://schemas.microsoft.com/office/drawing/2014/main" id="{6B7A2998-0CCF-4C18-A8C9-F0D9061E3A51}"/>
               </a:ext>
             </a:extLst>
           </p:cNvPr>
@@ -2352,7 +2352,7 @@
     </p:spTree>
     <p:extLst>
       <p:ext uri="{BB962C8B-B14F-4D97-AF65-F5344CB8AC3E}">
-        <p14:creationId xmlns:p14="http://schemas.microsoft.com/office/powerpoint/2010/main" val="666162872"/>
+        <p14:creationId xmlns:p14="http://schemas.microsoft.com/office/powerpoint/2010/main" val="652100338"/>
       </p:ext>
     </p:extLst>
   </p:cSld>
@@ -2383,7 +2383,7 @@
           <p:cNvPr id="16" name="">
             <a:extLst xmlns:a="http://schemas.openxmlformats.org/drawingml/2006/main">
               <a:ext uri="{FF2B5EF4-FFF2-40B4-BE49-F238E27FC236}">
-                <a16:creationId xmlns:a16="http://schemas.microsoft.com/office/drawing/2014/main" id="{6946A45F-6161-46D8-B806-2817AF6504E1}"/>
+                <a16:creationId xmlns:a16="http://schemas.microsoft.com/office/drawing/2014/main" id="{34DA9AD2-B627-4A7F-BFC4-F13DB87AE6DD}"/>
               </a:ext>
             </a:extLst>
           </p:cNvPr>
@@ -2440,7 +2440,7 @@
           <p:cNvPr id="2" name="">
             <a:extLst xmlns:a="http://schemas.openxmlformats.org/drawingml/2006/main">
               <a:ext uri="{FF2B5EF4-FFF2-40B4-BE49-F238E27FC236}">
-                <a16:creationId xmlns:a16="http://schemas.microsoft.com/office/drawing/2014/main" id="{C0D93F9D-A9BB-490F-A8CB-7DCD57C60A1E}"/>
+                <a16:creationId xmlns:a16="http://schemas.microsoft.com/office/drawing/2014/main" id="{E074CBAB-70DF-4949-8CBD-1ABE5F89914D}"/>
               </a:ext>
             </a:extLst>
           </p:cNvPr>
@@ -2497,7 +2497,7 @@
           <p:cNvPr id="3" name="">
             <a:extLst xmlns:a="http://schemas.openxmlformats.org/drawingml/2006/main">
               <a:ext uri="{FF2B5EF4-FFF2-40B4-BE49-F238E27FC236}">
-                <a16:creationId xmlns:a16="http://schemas.microsoft.com/office/drawing/2014/main" id="{3A9A4C70-16D8-4F29-87C1-6CD22A458394}"/>
+                <a16:creationId xmlns:a16="http://schemas.microsoft.com/office/drawing/2014/main" id="{737DA474-FD1F-4AAB-BFF9-222C463138C9}"/>
               </a:ext>
             </a:extLst>
           </p:cNvPr>
@@ -2527,7 +2527,7 @@
           <p:cNvPr id="4" name="">
             <a:extLst xmlns:a="http://schemas.openxmlformats.org/drawingml/2006/main">
               <a:ext uri="{FF2B5EF4-FFF2-40B4-BE49-F238E27FC236}">
-                <a16:creationId xmlns:a16="http://schemas.microsoft.com/office/drawing/2014/main" id="{B4ACAA5C-09B9-46B1-B439-FCC0DC774552}"/>
+                <a16:creationId xmlns:a16="http://schemas.microsoft.com/office/drawing/2014/main" id="{FF347041-CE6F-4DD1-BEC3-91EB9A13532D}"/>
               </a:ext>
             </a:extLst>
           </p:cNvPr>
@@ -2584,7 +2584,7 @@
           <p:cNvPr id="5" name="">
             <a:extLst xmlns:a="http://schemas.openxmlformats.org/drawingml/2006/main">
               <a:ext uri="{FF2B5EF4-FFF2-40B4-BE49-F238E27FC236}">
-                <a16:creationId xmlns:a16="http://schemas.microsoft.com/office/drawing/2014/main" id="{7D208C06-6702-4C68-85D8-3F0C59D84E0B}"/>
+                <a16:creationId xmlns:a16="http://schemas.microsoft.com/office/drawing/2014/main" id="{4849F5B4-B8FE-48A9-8C99-16EB3D9846D3}"/>
               </a:ext>
             </a:extLst>
           </p:cNvPr>
@@ -2641,7 +2641,7 @@
           <p:cNvPr id="6" name="">
             <a:extLst xmlns:a="http://schemas.openxmlformats.org/drawingml/2006/main">
               <a:ext uri="{FF2B5EF4-FFF2-40B4-BE49-F238E27FC236}">
-                <a16:creationId xmlns:a16="http://schemas.microsoft.com/office/drawing/2014/main" id="{4C107908-98E5-48F6-BBE6-3F5601884381}"/>
+                <a16:creationId xmlns:a16="http://schemas.microsoft.com/office/drawing/2014/main" id="{827DE068-146B-47F3-9C96-B38F7B924816}"/>
               </a:ext>
             </a:extLst>
           </p:cNvPr>
@@ -2653,24 +2653,24 @@
         <p:spPr>
           <a:xfrm xmlns:a="http://schemas.openxmlformats.org/drawingml/2006/main">
             <a:off x="1981200" y="2095500"/>
-            <a:ext cx="2286000" cy="619125"/>
-          </a:xfrm>
-          <a:prstGeom xmlns:a="http://schemas.openxmlformats.org/drawingml/2006/main" prst="rect">
-            <a:avLst/>
-          </a:prstGeom>
-          <a:noFill xmlns:a="http://schemas.openxmlformats.org/drawingml/2006/main"/>
-          <a:ln xmlns:a="http://schemas.openxmlformats.org/drawingml/2006/main" w="0">
-            <a:noFill/>
-          </a:ln>
-        </p:spPr>
-        <p:txBody>
-          <a:bodyPr xmlns:a="http://schemas.openxmlformats.org/drawingml/2006/main" anchor="ctr">
-            <a:noAutofit/>
-          </a:bodyPr>
-          <a:lstStyle xmlns:a="http://schemas.openxmlformats.org/drawingml/2006/main"/>
-          <a:p xmlns:a="http://schemas.openxmlformats.org/drawingml/2006/main">
-            <a:pPr>
-              <a:defRPr sz="2625" b="1">
+            <a:ext cx="2667000" cy="619125"/>
+          </a:xfrm>
+          <a:prstGeom xmlns:a="http://schemas.openxmlformats.org/drawingml/2006/main" prst="rect">
+            <a:avLst/>
+          </a:prstGeom>
+          <a:noFill xmlns:a="http://schemas.openxmlformats.org/drawingml/2006/main"/>
+          <a:ln xmlns:a="http://schemas.openxmlformats.org/drawingml/2006/main" w="0">
+            <a:noFill/>
+          </a:ln>
+        </p:spPr>
+        <p:txBody>
+          <a:bodyPr xmlns:a="http://schemas.openxmlformats.org/drawingml/2006/main" anchor="ctr">
+            <a:noAutofit/>
+          </a:bodyPr>
+          <a:lstStyle xmlns:a="http://schemas.openxmlformats.org/drawingml/2006/main"/>
+          <a:p xmlns:a="http://schemas.openxmlformats.org/drawingml/2006/main">
+            <a:pPr>
+              <a:defRPr sz="2400" b="1">
                 <a:solidFill>
                   <a:srgbClr val="FFFFFF"/>
                 </a:solidFill>
@@ -2680,7 +2680,7 @@
               </a:defRPr>
             </a:pPr>
             <a:r>
-              <a:rPr sz="2625" b="1">
+              <a:rPr sz="2400" b="1">
                 <a:solidFill>
                   <a:srgbClr val="FFFFFF"/>
                 </a:solidFill>
@@ -2698,19 +2698,19 @@
           <p:cNvPr id="7" name="">
             <a:extLst xmlns:a="http://schemas.openxmlformats.org/drawingml/2006/main">
               <a:ext uri="{FF2B5EF4-FFF2-40B4-BE49-F238E27FC236}">
-                <a16:creationId xmlns:a16="http://schemas.microsoft.com/office/drawing/2014/main" id="{520DB108-E15A-4D9F-AE9F-C0ACC9CF9276}"/>
-              </a:ext>
-            </a:extLst>
-          </p:cNvPr>
-          <p:cNvSpPr>
-            <a:spLocks xmlns:a="http://schemas.openxmlformats.org/drawingml/2006/main" noGrp="1"/>
-          </p:cNvSpPr>
-          <p:nvPr/>
-        </p:nvSpPr>
-        <p:spPr>
-          <a:xfrm xmlns:a="http://schemas.openxmlformats.org/drawingml/2006/main">
-            <a:off x="4524375" y="2143125"/>
-            <a:ext cx="6572250" cy="571500"/>
+                <a16:creationId xmlns:a16="http://schemas.microsoft.com/office/drawing/2014/main" id="{A2498C75-AF05-453C-995A-7D8F4C1ABB05}"/>
+              </a:ext>
+            </a:extLst>
+          </p:cNvPr>
+          <p:cNvSpPr>
+            <a:spLocks xmlns:a="http://schemas.openxmlformats.org/drawingml/2006/main" noGrp="1"/>
+          </p:cNvSpPr>
+          <p:nvPr/>
+        </p:nvSpPr>
+        <p:spPr>
+          <a:xfrm xmlns:a="http://schemas.openxmlformats.org/drawingml/2006/main">
+            <a:off x="4857750" y="2143125"/>
+            <a:ext cx="6286500" cy="571500"/>
           </a:xfrm>
           <a:prstGeom xmlns:a="http://schemas.openxmlformats.org/drawingml/2006/main" prst="rect">
             <a:avLst/>
@@ -2755,7 +2755,7 @@
           <p:cNvPr id="8" name="">
             <a:extLst xmlns:a="http://schemas.openxmlformats.org/drawingml/2006/main">
               <a:ext uri="{FF2B5EF4-FFF2-40B4-BE49-F238E27FC236}">
-                <a16:creationId xmlns:a16="http://schemas.microsoft.com/office/drawing/2014/main" id="{4F28D4CE-3ED3-4949-BA5A-FF25044C43E8}"/>
+                <a16:creationId xmlns:a16="http://schemas.microsoft.com/office/drawing/2014/main" id="{FC18023B-BE58-48AC-A687-BF544FE2AA78}"/>
               </a:ext>
             </a:extLst>
           </p:cNvPr>
@@ -2785,7 +2785,7 @@
           <p:cNvPr id="9" name="">
             <a:extLst xmlns:a="http://schemas.openxmlformats.org/drawingml/2006/main">
               <a:ext uri="{FF2B5EF4-FFF2-40B4-BE49-F238E27FC236}">
-                <a16:creationId xmlns:a16="http://schemas.microsoft.com/office/drawing/2014/main" id="{CFF214A6-00D1-4329-8550-8E0093E5B160}"/>
+                <a16:creationId xmlns:a16="http://schemas.microsoft.com/office/drawing/2014/main" id="{6CC7DA0E-42F5-43EF-83ED-A40207CE1A39}"/>
               </a:ext>
             </a:extLst>
           </p:cNvPr>
@@ -2842,7 +2842,7 @@
           <p:cNvPr id="10" name="">
             <a:extLst xmlns:a="http://schemas.openxmlformats.org/drawingml/2006/main">
               <a:ext uri="{FF2B5EF4-FFF2-40B4-BE49-F238E27FC236}">
-                <a16:creationId xmlns:a16="http://schemas.microsoft.com/office/drawing/2014/main" id="{F098B5AA-C1F5-4350-894E-D856C7131448}"/>
+                <a16:creationId xmlns:a16="http://schemas.microsoft.com/office/drawing/2014/main" id="{05523984-4E6D-4BA9-936C-5A6704FCDBAE}"/>
               </a:ext>
             </a:extLst>
           </p:cNvPr>
@@ -2854,24 +2854,24 @@
         <p:spPr>
           <a:xfrm xmlns:a="http://schemas.openxmlformats.org/drawingml/2006/main">
             <a:off x="1981200" y="3390900"/>
-            <a:ext cx="2286000" cy="619125"/>
-          </a:xfrm>
-          <a:prstGeom xmlns:a="http://schemas.openxmlformats.org/drawingml/2006/main" prst="rect">
-            <a:avLst/>
-          </a:prstGeom>
-          <a:noFill xmlns:a="http://schemas.openxmlformats.org/drawingml/2006/main"/>
-          <a:ln xmlns:a="http://schemas.openxmlformats.org/drawingml/2006/main" w="0">
-            <a:noFill/>
-          </a:ln>
-        </p:spPr>
-        <p:txBody>
-          <a:bodyPr xmlns:a="http://schemas.openxmlformats.org/drawingml/2006/main" anchor="ctr">
-            <a:noAutofit/>
-          </a:bodyPr>
-          <a:lstStyle xmlns:a="http://schemas.openxmlformats.org/drawingml/2006/main"/>
-          <a:p xmlns:a="http://schemas.openxmlformats.org/drawingml/2006/main">
-            <a:pPr>
-              <a:defRPr sz="2625" b="1">
+            <a:ext cx="2667000" cy="619125"/>
+          </a:xfrm>
+          <a:prstGeom xmlns:a="http://schemas.openxmlformats.org/drawingml/2006/main" prst="rect">
+            <a:avLst/>
+          </a:prstGeom>
+          <a:noFill xmlns:a="http://schemas.openxmlformats.org/drawingml/2006/main"/>
+          <a:ln xmlns:a="http://schemas.openxmlformats.org/drawingml/2006/main" w="0">
+            <a:noFill/>
+          </a:ln>
+        </p:spPr>
+        <p:txBody>
+          <a:bodyPr xmlns:a="http://schemas.openxmlformats.org/drawingml/2006/main" anchor="ctr">
+            <a:noAutofit/>
+          </a:bodyPr>
+          <a:lstStyle xmlns:a="http://schemas.openxmlformats.org/drawingml/2006/main"/>
+          <a:p xmlns:a="http://schemas.openxmlformats.org/drawingml/2006/main">
+            <a:pPr>
+              <a:defRPr sz="2400" b="1">
                 <a:solidFill>
                   <a:srgbClr val="FFFFFF"/>
                 </a:solidFill>
@@ -2881,7 +2881,7 @@
               </a:defRPr>
             </a:pPr>
             <a:r>
-              <a:rPr sz="2625" b="1">
+              <a:rPr sz="2400" b="1">
                 <a:solidFill>
                   <a:srgbClr val="FFFFFF"/>
                 </a:solidFill>
@@ -2889,7 +2889,7 @@
                 <a:ea typeface="Arial"/>
                 <a:cs typeface="Arial"/>
               </a:rPr>
-              <a:t>Report</a:t>
+              <a:t>Report + relay</a:t>
             </a:r>
           </a:p>
         </p:txBody>
@@ -2899,19 +2899,19 @@
           <p:cNvPr id="11" name="">
             <a:extLst xmlns:a="http://schemas.openxmlformats.org/drawingml/2006/main">
               <a:ext uri="{FF2B5EF4-FFF2-40B4-BE49-F238E27FC236}">
-                <a16:creationId xmlns:a16="http://schemas.microsoft.com/office/drawing/2014/main" id="{FC0B2AA3-1953-4EEC-AECD-D27D4DDAE84A}"/>
-              </a:ext>
-            </a:extLst>
-          </p:cNvPr>
-          <p:cNvSpPr>
-            <a:spLocks xmlns:a="http://schemas.openxmlformats.org/drawingml/2006/main" noGrp="1"/>
-          </p:cNvSpPr>
-          <p:nvPr/>
-        </p:nvSpPr>
-        <p:spPr>
-          <a:xfrm xmlns:a="http://schemas.openxmlformats.org/drawingml/2006/main">
-            <a:off x="4524375" y="3438525"/>
-            <a:ext cx="6572250" cy="571500"/>
+                <a16:creationId xmlns:a16="http://schemas.microsoft.com/office/drawing/2014/main" id="{E7ED4D54-E796-48D3-9766-B55CFFCD78F6}"/>
+              </a:ext>
+            </a:extLst>
+          </p:cNvPr>
+          <p:cNvSpPr>
+            <a:spLocks xmlns:a="http://schemas.openxmlformats.org/drawingml/2006/main" noGrp="1"/>
+          </p:cNvSpPr>
+          <p:nvPr/>
+        </p:nvSpPr>
+        <p:spPr>
+          <a:xfrm xmlns:a="http://schemas.openxmlformats.org/drawingml/2006/main">
+            <a:off x="4857750" y="3438525"/>
+            <a:ext cx="6286500" cy="571500"/>
           </a:xfrm>
           <a:prstGeom xmlns:a="http://schemas.openxmlformats.org/drawingml/2006/main" prst="rect">
             <a:avLst/>
@@ -2946,7 +2946,7 @@
                 <a:ea typeface="Arial"/>
                 <a:cs typeface="Arial"/>
               </a:rPr>
-              <a:t>Send a short, structured need report in the local demo.</a:t>
+              <a:t>Create a report; carry a short code between devices.</a:t>
             </a:r>
           </a:p>
         </p:txBody>
@@ -2956,7 +2956,7 @@
           <p:cNvPr id="12" name="">
             <a:extLst xmlns:a="http://schemas.openxmlformats.org/drawingml/2006/main">
               <a:ext uri="{FF2B5EF4-FFF2-40B4-BE49-F238E27FC236}">
-                <a16:creationId xmlns:a16="http://schemas.microsoft.com/office/drawing/2014/main" id="{73B9E25A-8FAC-45BE-80ED-5C50DBE9B954}"/>
+                <a16:creationId xmlns:a16="http://schemas.microsoft.com/office/drawing/2014/main" id="{0A4ED159-5076-4AE2-9229-30D43D713F5E}"/>
               </a:ext>
             </a:extLst>
           </p:cNvPr>
@@ -2986,7 +2986,7 @@
           <p:cNvPr id="13" name="">
             <a:extLst xmlns:a="http://schemas.openxmlformats.org/drawingml/2006/main">
               <a:ext uri="{FF2B5EF4-FFF2-40B4-BE49-F238E27FC236}">
-                <a16:creationId xmlns:a16="http://schemas.microsoft.com/office/drawing/2014/main" id="{A31AE28C-AD8B-44E7-B942-2F3A70B349E7}"/>
+                <a16:creationId xmlns:a16="http://schemas.microsoft.com/office/drawing/2014/main" id="{17D796BE-E637-4F29-9D41-814AF06C105E}"/>
               </a:ext>
             </a:extLst>
           </p:cNvPr>
@@ -3043,7 +3043,7 @@
           <p:cNvPr id="14" name="">
             <a:extLst xmlns:a="http://schemas.openxmlformats.org/drawingml/2006/main">
               <a:ext uri="{FF2B5EF4-FFF2-40B4-BE49-F238E27FC236}">
-                <a16:creationId xmlns:a16="http://schemas.microsoft.com/office/drawing/2014/main" id="{FCD2E3CF-0041-4B00-A4B0-9D59D37EC089}"/>
+                <a16:creationId xmlns:a16="http://schemas.microsoft.com/office/drawing/2014/main" id="{E24AB495-8FA1-49FD-919B-20C4E9614BD9}"/>
               </a:ext>
             </a:extLst>
           </p:cNvPr>
@@ -3055,24 +3055,24 @@
         <p:spPr>
           <a:xfrm xmlns:a="http://schemas.openxmlformats.org/drawingml/2006/main">
             <a:off x="1981200" y="4686300"/>
-            <a:ext cx="2286000" cy="619125"/>
-          </a:xfrm>
-          <a:prstGeom xmlns:a="http://schemas.openxmlformats.org/drawingml/2006/main" prst="rect">
-            <a:avLst/>
-          </a:prstGeom>
-          <a:noFill xmlns:a="http://schemas.openxmlformats.org/drawingml/2006/main"/>
-          <a:ln xmlns:a="http://schemas.openxmlformats.org/drawingml/2006/main" w="0">
-            <a:noFill/>
-          </a:ln>
-        </p:spPr>
-        <p:txBody>
-          <a:bodyPr xmlns:a="http://schemas.openxmlformats.org/drawingml/2006/main" anchor="ctr">
-            <a:noAutofit/>
-          </a:bodyPr>
-          <a:lstStyle xmlns:a="http://schemas.openxmlformats.org/drawingml/2006/main"/>
-          <a:p xmlns:a="http://schemas.openxmlformats.org/drawingml/2006/main">
-            <a:pPr>
-              <a:defRPr sz="2625" b="1">
+            <a:ext cx="2667000" cy="619125"/>
+          </a:xfrm>
+          <a:prstGeom xmlns:a="http://schemas.openxmlformats.org/drawingml/2006/main" prst="rect">
+            <a:avLst/>
+          </a:prstGeom>
+          <a:noFill xmlns:a="http://schemas.openxmlformats.org/drawingml/2006/main"/>
+          <a:ln xmlns:a="http://schemas.openxmlformats.org/drawingml/2006/main" w="0">
+            <a:noFill/>
+          </a:ln>
+        </p:spPr>
+        <p:txBody>
+          <a:bodyPr xmlns:a="http://schemas.openxmlformats.org/drawingml/2006/main" anchor="ctr">
+            <a:noAutofit/>
+          </a:bodyPr>
+          <a:lstStyle xmlns:a="http://schemas.openxmlformats.org/drawingml/2006/main"/>
+          <a:p xmlns:a="http://schemas.openxmlformats.org/drawingml/2006/main">
+            <a:pPr>
+              <a:defRPr sz="2400" b="1">
                 <a:solidFill>
                   <a:srgbClr val="FFFFFF"/>
                 </a:solidFill>
@@ -3082,7 +3082,7 @@
               </a:defRPr>
             </a:pPr>
             <a:r>
-              <a:rPr sz="2625" b="1">
+              <a:rPr sz="2400" b="1">
                 <a:solidFill>
                   <a:srgbClr val="FFFFFF"/>
                 </a:solidFill>
@@ -3100,19 +3100,19 @@
           <p:cNvPr id="15" name="">
             <a:extLst xmlns:a="http://schemas.openxmlformats.org/drawingml/2006/main">
               <a:ext uri="{FF2B5EF4-FFF2-40B4-BE49-F238E27FC236}">
-                <a16:creationId xmlns:a16="http://schemas.microsoft.com/office/drawing/2014/main" id="{5E1880C4-2256-4A6E-A799-60FF07D1CB13}"/>
-              </a:ext>
-            </a:extLst>
-          </p:cNvPr>
-          <p:cNvSpPr>
-            <a:spLocks xmlns:a="http://schemas.openxmlformats.org/drawingml/2006/main" noGrp="1"/>
-          </p:cNvSpPr>
-          <p:nvPr/>
-        </p:nvSpPr>
-        <p:spPr>
-          <a:xfrm xmlns:a="http://schemas.openxmlformats.org/drawingml/2006/main">
-            <a:off x="4524375" y="4733925"/>
-            <a:ext cx="6572250" cy="571500"/>
+                <a16:creationId xmlns:a16="http://schemas.microsoft.com/office/drawing/2014/main" id="{76F98EBD-8E9C-4DC9-BDD4-D7458F63C3A7}"/>
+              </a:ext>
+            </a:extLst>
+          </p:cNvPr>
+          <p:cNvSpPr>
+            <a:spLocks xmlns:a="http://schemas.openxmlformats.org/drawingml/2006/main" noGrp="1"/>
+          </p:cNvSpPr>
+          <p:nvPr/>
+        </p:nvSpPr>
+        <p:spPr>
+          <a:xfrm xmlns:a="http://schemas.openxmlformats.org/drawingml/2006/main">
+            <a:off x="4857750" y="4733925"/>
+            <a:ext cx="6286500" cy="571500"/>
           </a:xfrm>
           <a:prstGeom xmlns:a="http://schemas.openxmlformats.org/drawingml/2006/main" prst="rect">
             <a:avLst/>
@@ -3147,7 +3147,7 @@
                 <a:ea typeface="Arial"/>
                 <a:cs typeface="Arial"/>
               </a:rPr>
-              <a:t>See a ranked queue, matching resources, and manual assignment.</a:t>
+              <a:t>See explained priorities, reserved matches, and manual assignment.</a:t>
             </a:r>
           </a:p>
         </p:txBody>
@@ -3155,7 +3155,7 @@
     </p:spTree>
     <p:extLst>
       <p:ext uri="{BB962C8B-B14F-4D97-AF65-F5344CB8AC3E}">
-        <p14:creationId xmlns:p14="http://schemas.microsoft.com/office/powerpoint/2010/main" val="542145981"/>
+        <p14:creationId xmlns:p14="http://schemas.microsoft.com/office/powerpoint/2010/main" val="664065285"/>
       </p:ext>
     </p:extLst>
   </p:cSld>
@@ -3186,7 +3186,7 @@
           <p:cNvPr id="19" name="">
             <a:extLst xmlns:a="http://schemas.openxmlformats.org/drawingml/2006/main">
               <a:ext uri="{FF2B5EF4-FFF2-40B4-BE49-F238E27FC236}">
-                <a16:creationId xmlns:a16="http://schemas.microsoft.com/office/drawing/2014/main" id="{598B7708-70F2-400F-8CDD-13C43F748ED3}"/>
+                <a16:creationId xmlns:a16="http://schemas.microsoft.com/office/drawing/2014/main" id="{EE28A85C-253C-4353-92BD-2BC589E4B482}"/>
               </a:ext>
             </a:extLst>
           </p:cNvPr>
@@ -3243,7 +3243,7 @@
           <p:cNvPr id="2" name="">
             <a:extLst xmlns:a="http://schemas.openxmlformats.org/drawingml/2006/main">
               <a:ext uri="{FF2B5EF4-FFF2-40B4-BE49-F238E27FC236}">
-                <a16:creationId xmlns:a16="http://schemas.microsoft.com/office/drawing/2014/main" id="{0F3010D6-0F3F-4B64-A5C4-7976641CC3AF}"/>
+                <a16:creationId xmlns:a16="http://schemas.microsoft.com/office/drawing/2014/main" id="{85CEB31A-D061-4622-93F2-4F3A70EBCEC5}"/>
               </a:ext>
             </a:extLst>
           </p:cNvPr>
@@ -3300,7 +3300,7 @@
           <p:cNvPr id="3" name="">
             <a:extLst xmlns:a="http://schemas.openxmlformats.org/drawingml/2006/main">
               <a:ext uri="{FF2B5EF4-FFF2-40B4-BE49-F238E27FC236}">
-                <a16:creationId xmlns:a16="http://schemas.microsoft.com/office/drawing/2014/main" id="{CB8C7676-29C0-4238-B6DC-4538BEB1A090}"/>
+                <a16:creationId xmlns:a16="http://schemas.microsoft.com/office/drawing/2014/main" id="{EE53DB99-06E2-4ABE-B49A-A9E76D1C2759}"/>
               </a:ext>
             </a:extLst>
           </p:cNvPr>
@@ -3330,7 +3330,7 @@
           <p:cNvPr id="4" name="">
             <a:extLst xmlns:a="http://schemas.openxmlformats.org/drawingml/2006/main">
               <a:ext uri="{FF2B5EF4-FFF2-40B4-BE49-F238E27FC236}">
-                <a16:creationId xmlns:a16="http://schemas.microsoft.com/office/drawing/2014/main" id="{74A0B4DF-B092-4346-B2E3-DD00DC917395}"/>
+                <a16:creationId xmlns:a16="http://schemas.microsoft.com/office/drawing/2014/main" id="{9F235BBF-A703-4A92-A135-DCDF88B6B6CC}"/>
               </a:ext>
             </a:extLst>
           </p:cNvPr>
@@ -3387,7 +3387,7 @@
           <p:cNvPr id="5" name="">
             <a:extLst xmlns:a="http://schemas.openxmlformats.org/drawingml/2006/main">
               <a:ext uri="{FF2B5EF4-FFF2-40B4-BE49-F238E27FC236}">
-                <a16:creationId xmlns:a16="http://schemas.microsoft.com/office/drawing/2014/main" id="{AC479DC2-D5F4-4F7D-ABE0-49CAB8106666}"/>
+                <a16:creationId xmlns:a16="http://schemas.microsoft.com/office/drawing/2014/main" id="{E4A9F28B-EA2E-4FFA-B0E9-A97EC76A824A}"/>
               </a:ext>
             </a:extLst>
           </p:cNvPr>
@@ -3444,7 +3444,7 @@
           <p:cNvPr id="6" name="">
             <a:extLst xmlns:a="http://schemas.openxmlformats.org/drawingml/2006/main">
               <a:ext uri="{FF2B5EF4-FFF2-40B4-BE49-F238E27FC236}">
-                <a16:creationId xmlns:a16="http://schemas.microsoft.com/office/drawing/2014/main" id="{3047016C-ACD0-4C27-B1E3-8C4CEBCE119D}"/>
+                <a16:creationId xmlns:a16="http://schemas.microsoft.com/office/drawing/2014/main" id="{29142D11-3C37-413D-953F-7BC4C37789A2}"/>
               </a:ext>
             </a:extLst>
           </p:cNvPr>
@@ -3501,7 +3501,7 @@
           <p:cNvPr id="7" name="">
             <a:extLst xmlns:a="http://schemas.openxmlformats.org/drawingml/2006/main">
               <a:ext uri="{FF2B5EF4-FFF2-40B4-BE49-F238E27FC236}">
-                <a16:creationId xmlns:a16="http://schemas.microsoft.com/office/drawing/2014/main" id="{3D928BA1-F341-42F1-BD8D-F69D7D106E30}"/>
+                <a16:creationId xmlns:a16="http://schemas.microsoft.com/office/drawing/2014/main" id="{E7FA031D-5405-4CBC-A509-686D09F1FB9D}"/>
               </a:ext>
             </a:extLst>
           </p:cNvPr>
@@ -3531,7 +3531,7 @@
           <p:cNvPr id="8" name="">
             <a:extLst xmlns:a="http://schemas.openxmlformats.org/drawingml/2006/main">
               <a:ext uri="{FF2B5EF4-FFF2-40B4-BE49-F238E27FC236}">
-                <a16:creationId xmlns:a16="http://schemas.microsoft.com/office/drawing/2014/main" id="{51275E3D-154A-4D15-9601-3CA3B28BE4FD}"/>
+                <a16:creationId xmlns:a16="http://schemas.microsoft.com/office/drawing/2014/main" id="{ADB0E427-BE21-4F9D-9BDC-6EBD87EC898C}"/>
               </a:ext>
             </a:extLst>
           </p:cNvPr>
@@ -3588,7 +3588,7 @@
           <p:cNvPr id="9" name="">
             <a:extLst xmlns:a="http://schemas.openxmlformats.org/drawingml/2006/main">
               <a:ext uri="{FF2B5EF4-FFF2-40B4-BE49-F238E27FC236}">
-                <a16:creationId xmlns:a16="http://schemas.microsoft.com/office/drawing/2014/main" id="{DDBFFFD0-D285-4651-8F23-AFDB1ED2774B}"/>
+                <a16:creationId xmlns:a16="http://schemas.microsoft.com/office/drawing/2014/main" id="{9F0F5C57-C817-46BA-90C4-DEDF79820511}"/>
               </a:ext>
             </a:extLst>
           </p:cNvPr>
@@ -3645,7 +3645,7 @@
           <p:cNvPr id="10" name="">
             <a:extLst xmlns:a="http://schemas.openxmlformats.org/drawingml/2006/main">
               <a:ext uri="{FF2B5EF4-FFF2-40B4-BE49-F238E27FC236}">
-                <a16:creationId xmlns:a16="http://schemas.microsoft.com/office/drawing/2014/main" id="{A2C4E7F7-8579-45E4-B15C-E2BA096CB58A}"/>
+                <a16:creationId xmlns:a16="http://schemas.microsoft.com/office/drawing/2014/main" id="{41D0D0B2-32B1-402D-8A67-E40C8CA5B7C3}"/>
               </a:ext>
             </a:extLst>
           </p:cNvPr>
@@ -3702,7 +3702,7 @@
           <p:cNvPr id="11" name="">
             <a:extLst xmlns:a="http://schemas.openxmlformats.org/drawingml/2006/main">
               <a:ext uri="{FF2B5EF4-FFF2-40B4-BE49-F238E27FC236}">
-                <a16:creationId xmlns:a16="http://schemas.microsoft.com/office/drawing/2014/main" id="{EEFD4D1A-6758-49A3-BB5B-B55881DC3E00}"/>
+                <a16:creationId xmlns:a16="http://schemas.microsoft.com/office/drawing/2014/main" id="{308D8EB8-22B8-4C34-945C-293288CADB22}"/>
               </a:ext>
             </a:extLst>
           </p:cNvPr>
@@ -3759,7 +3759,7 @@
           <p:cNvPr id="12" name="">
             <a:extLst xmlns:a="http://schemas.openxmlformats.org/drawingml/2006/main">
               <a:ext uri="{FF2B5EF4-FFF2-40B4-BE49-F238E27FC236}">
-                <a16:creationId xmlns:a16="http://schemas.microsoft.com/office/drawing/2014/main" id="{0958283D-4923-4D17-A03F-CE62898C1D7A}"/>
+                <a16:creationId xmlns:a16="http://schemas.microsoft.com/office/drawing/2014/main" id="{3D73B127-83A9-450B-909C-0035B5937D0E}"/>
               </a:ext>
             </a:extLst>
           </p:cNvPr>
@@ -3816,7 +3816,7 @@
           <p:cNvPr id="13" name="">
             <a:extLst xmlns:a="http://schemas.openxmlformats.org/drawingml/2006/main">
               <a:ext uri="{FF2B5EF4-FFF2-40B4-BE49-F238E27FC236}">
-                <a16:creationId xmlns:a16="http://schemas.microsoft.com/office/drawing/2014/main" id="{B5A4C753-A1B7-47C2-836F-19162D719867}"/>
+                <a16:creationId xmlns:a16="http://schemas.microsoft.com/office/drawing/2014/main" id="{D399B8AE-1224-4173-B27D-D289776BF926}"/>
               </a:ext>
             </a:extLst>
           </p:cNvPr>
@@ -3873,7 +3873,7 @@
           <p:cNvPr id="14" name="">
             <a:extLst xmlns:a="http://schemas.openxmlformats.org/drawingml/2006/main">
               <a:ext uri="{FF2B5EF4-FFF2-40B4-BE49-F238E27FC236}">
-                <a16:creationId xmlns:a16="http://schemas.microsoft.com/office/drawing/2014/main" id="{C925F8CE-3EA8-4DB6-93EA-B67773183C8E}"/>
+                <a16:creationId xmlns:a16="http://schemas.microsoft.com/office/drawing/2014/main" id="{1DF329F6-0BAC-4CF0-861E-986816C8D428}"/>
               </a:ext>
             </a:extLst>
           </p:cNvPr>
@@ -3903,7 +3903,7 @@
           <p:cNvPr id="15" name="">
             <a:extLst xmlns:a="http://schemas.openxmlformats.org/drawingml/2006/main">
               <a:ext uri="{FF2B5EF4-FFF2-40B4-BE49-F238E27FC236}">
-                <a16:creationId xmlns:a16="http://schemas.microsoft.com/office/drawing/2014/main" id="{AE4E1449-4081-4E40-9A6F-B05182FB02FB}"/>
+                <a16:creationId xmlns:a16="http://schemas.microsoft.com/office/drawing/2014/main" id="{6E274558-19DF-4B0A-9006-35AA58F9A8DC}"/>
               </a:ext>
             </a:extLst>
           </p:cNvPr>
@@ -3933,7 +3933,7 @@
           <p:cNvPr id="16" name="">
             <a:extLst xmlns:a="http://schemas.openxmlformats.org/drawingml/2006/main">
               <a:ext uri="{FF2B5EF4-FFF2-40B4-BE49-F238E27FC236}">
-                <a16:creationId xmlns:a16="http://schemas.microsoft.com/office/drawing/2014/main" id="{D5FE7D9A-3043-49DB-920F-7ED33330647D}"/>
+                <a16:creationId xmlns:a16="http://schemas.microsoft.com/office/drawing/2014/main" id="{0F483BEF-4A38-4EEA-BA19-941BB52FC2DC}"/>
               </a:ext>
             </a:extLst>
           </p:cNvPr>
@@ -3990,7 +3990,7 @@
           <p:cNvPr id="17" name="">
             <a:extLst xmlns:a="http://schemas.openxmlformats.org/drawingml/2006/main">
               <a:ext uri="{FF2B5EF4-FFF2-40B4-BE49-F238E27FC236}">
-                <a16:creationId xmlns:a16="http://schemas.microsoft.com/office/drawing/2014/main" id="{CF31B662-B9F4-48F0-8440-F70A2B9B165E}"/>
+                <a16:creationId xmlns:a16="http://schemas.microsoft.com/office/drawing/2014/main" id="{D269A873-1EEB-4CCB-BE0F-FFC0AF97E8D4}"/>
               </a:ext>
             </a:extLst>
           </p:cNvPr>
@@ -4070,7 +4070,7 @@
           <p:cNvPr id="18" name="">
             <a:extLst xmlns:a="http://schemas.openxmlformats.org/drawingml/2006/main">
               <a:ext uri="{FF2B5EF4-FFF2-40B4-BE49-F238E27FC236}">
-                <a16:creationId xmlns:a16="http://schemas.microsoft.com/office/drawing/2014/main" id="{5037627A-0F54-4B2E-BEBD-9DC415A2C5ED}"/>
+                <a16:creationId xmlns:a16="http://schemas.microsoft.com/office/drawing/2014/main" id="{5A95140A-687D-4648-B0F1-56F581422F35}"/>
               </a:ext>
             </a:extLst>
           </p:cNvPr>
@@ -4125,7 +4125,7 @@
     </p:spTree>
     <p:extLst>
       <p:ext uri="{BB962C8B-B14F-4D97-AF65-F5344CB8AC3E}">
-        <p14:creationId xmlns:p14="http://schemas.microsoft.com/office/powerpoint/2010/main" val="293343533"/>
+        <p14:creationId xmlns:p14="http://schemas.microsoft.com/office/powerpoint/2010/main" val="629081160"/>
       </p:ext>
     </p:extLst>
   </p:cSld>
@@ -4156,7 +4156,7 @@
           <p:cNvPr id="15" name="">
             <a:extLst xmlns:a="http://schemas.openxmlformats.org/drawingml/2006/main">
               <a:ext uri="{FF2B5EF4-FFF2-40B4-BE49-F238E27FC236}">
-                <a16:creationId xmlns:a16="http://schemas.microsoft.com/office/drawing/2014/main" id="{A46F5506-B9BC-48FB-84C7-6D009EE6A213}"/>
+                <a16:creationId xmlns:a16="http://schemas.microsoft.com/office/drawing/2014/main" id="{7DC35BC9-F428-4532-8F45-44C2077C8B6C}"/>
               </a:ext>
             </a:extLst>
           </p:cNvPr>
@@ -4213,7 +4213,7 @@
           <p:cNvPr id="2" name="">
             <a:extLst xmlns:a="http://schemas.openxmlformats.org/drawingml/2006/main">
               <a:ext uri="{FF2B5EF4-FFF2-40B4-BE49-F238E27FC236}">
-                <a16:creationId xmlns:a16="http://schemas.microsoft.com/office/drawing/2014/main" id="{8C38BF7E-5CC9-41F7-A6D0-402489C6CFF0}"/>
+                <a16:creationId xmlns:a16="http://schemas.microsoft.com/office/drawing/2014/main" id="{17317CB9-F5A7-452D-BEA9-96D298D333D5}"/>
               </a:ext>
             </a:extLst>
           </p:cNvPr>
@@ -4270,7 +4270,7 @@
           <p:cNvPr id="3" name="">
             <a:extLst xmlns:a="http://schemas.openxmlformats.org/drawingml/2006/main">
               <a:ext uri="{FF2B5EF4-FFF2-40B4-BE49-F238E27FC236}">
-                <a16:creationId xmlns:a16="http://schemas.microsoft.com/office/drawing/2014/main" id="{BEFA2FCD-473D-4220-99B2-C31F3DC9FAB6}"/>
+                <a16:creationId xmlns:a16="http://schemas.microsoft.com/office/drawing/2014/main" id="{7E4C4506-44F2-4514-BD6E-FB1D41386049}"/>
               </a:ext>
             </a:extLst>
           </p:cNvPr>
@@ -4300,7 +4300,7 @@
           <p:cNvPr id="4" name="">
             <a:extLst xmlns:a="http://schemas.openxmlformats.org/drawingml/2006/main">
               <a:ext uri="{FF2B5EF4-FFF2-40B4-BE49-F238E27FC236}">
-                <a16:creationId xmlns:a16="http://schemas.microsoft.com/office/drawing/2014/main" id="{4FFF1724-C04B-4532-9A89-A01149A2E0C9}"/>
+                <a16:creationId xmlns:a16="http://schemas.microsoft.com/office/drawing/2014/main" id="{199BF1DF-80F6-4297-8E15-21DF7147988E}"/>
               </a:ext>
             </a:extLst>
           </p:cNvPr>
@@ -4357,7 +4357,7 @@
           <p:cNvPr id="5" name="">
             <a:extLst xmlns:a="http://schemas.openxmlformats.org/drawingml/2006/main">
               <a:ext uri="{FF2B5EF4-FFF2-40B4-BE49-F238E27FC236}">
-                <a16:creationId xmlns:a16="http://schemas.microsoft.com/office/drawing/2014/main" id="{4EC5F8F4-4633-4B28-ABCD-B42C2409A5C4}"/>
+                <a16:creationId xmlns:a16="http://schemas.microsoft.com/office/drawing/2014/main" id="{9C61BE58-AF8A-457B-8330-CFD88B402189}"/>
               </a:ext>
             </a:extLst>
           </p:cNvPr>
@@ -4414,7 +4414,7 @@
           <p:cNvPr id="6" name="">
             <a:extLst xmlns:a="http://schemas.openxmlformats.org/drawingml/2006/main">
               <a:ext uri="{FF2B5EF4-FFF2-40B4-BE49-F238E27FC236}">
-                <a16:creationId xmlns:a16="http://schemas.microsoft.com/office/drawing/2014/main" id="{3A45138E-5646-4B87-B10D-3269FAE56474}"/>
+                <a16:creationId xmlns:a16="http://schemas.microsoft.com/office/drawing/2014/main" id="{BC04F419-3C5F-42E0-847A-CFE90A5B687C}"/>
               </a:ext>
             </a:extLst>
           </p:cNvPr>
@@ -4471,7 +4471,7 @@
           <p:cNvPr id="7" name="">
             <a:extLst xmlns:a="http://schemas.openxmlformats.org/drawingml/2006/main">
               <a:ext uri="{FF2B5EF4-FFF2-40B4-BE49-F238E27FC236}">
-                <a16:creationId xmlns:a16="http://schemas.microsoft.com/office/drawing/2014/main" id="{D86237A5-A2B4-44AD-B526-80446AE06571}"/>
+                <a16:creationId xmlns:a16="http://schemas.microsoft.com/office/drawing/2014/main" id="{C7CE2E04-7913-49A5-99B4-B14FBCBC1255}"/>
               </a:ext>
             </a:extLst>
           </p:cNvPr>
@@ -4528,7 +4528,7 @@
           <p:cNvPr id="8" name="">
             <a:extLst xmlns:a="http://schemas.openxmlformats.org/drawingml/2006/main">
               <a:ext uri="{FF2B5EF4-FFF2-40B4-BE49-F238E27FC236}">
-                <a16:creationId xmlns:a16="http://schemas.microsoft.com/office/drawing/2014/main" id="{07029FEC-99E8-4059-B2A6-F4A3014102FC}"/>
+                <a16:creationId xmlns:a16="http://schemas.microsoft.com/office/drawing/2014/main" id="{AD3F77E2-8DDD-4C14-9869-D94E2286D063}"/>
               </a:ext>
             </a:extLst>
           </p:cNvPr>
@@ -4585,7 +4585,7 @@
           <p:cNvPr id="9" name="">
             <a:extLst xmlns:a="http://schemas.openxmlformats.org/drawingml/2006/main">
               <a:ext uri="{FF2B5EF4-FFF2-40B4-BE49-F238E27FC236}">
-                <a16:creationId xmlns:a16="http://schemas.microsoft.com/office/drawing/2014/main" id="{7DECB46E-5715-4146-83A0-D9B06A7AB411}"/>
+                <a16:creationId xmlns:a16="http://schemas.microsoft.com/office/drawing/2014/main" id="{5A57E0CA-F9CC-458D-8DB3-E8E071B5E1FE}"/>
               </a:ext>
             </a:extLst>
           </p:cNvPr>
@@ -4632,7 +4632,7 @@
                 <a:ea typeface="Arial"/>
                 <a:cs typeface="Arial"/>
               </a:rPr>
-              <a:t>Suggested resource: medical backup-power team  ·  1 available</a:t>
+              <a:t>Reserved suggestion: medical backup-power team  ·  1 available</a:t>
             </a:r>
           </a:p>
         </p:txBody>
@@ -4642,7 +4642,7 @@
           <p:cNvPr id="10" name="">
             <a:extLst xmlns:a="http://schemas.openxmlformats.org/drawingml/2006/main">
               <a:ext uri="{FF2B5EF4-FFF2-40B4-BE49-F238E27FC236}">
-                <a16:creationId xmlns:a16="http://schemas.microsoft.com/office/drawing/2014/main" id="{10A7888F-1B23-41E9-8FCD-52A28314594C}"/>
+                <a16:creationId xmlns:a16="http://schemas.microsoft.com/office/drawing/2014/main" id="{DE436C35-DDD9-4C7F-BF8C-DB04FFC0BE0A}"/>
               </a:ext>
             </a:extLst>
           </p:cNvPr>
@@ -4672,7 +4672,7 @@
           <p:cNvPr id="11" name="">
             <a:extLst xmlns:a="http://schemas.openxmlformats.org/drawingml/2006/main">
               <a:ext uri="{FF2B5EF4-FFF2-40B4-BE49-F238E27FC236}">
-                <a16:creationId xmlns:a16="http://schemas.microsoft.com/office/drawing/2014/main" id="{75DBEFF1-258A-473B-B7B6-33031A09275C}"/>
+                <a16:creationId xmlns:a16="http://schemas.microsoft.com/office/drawing/2014/main" id="{B1327CB1-1CCB-45B7-83A1-CD44AF54D927}"/>
               </a:ext>
             </a:extLst>
           </p:cNvPr>
@@ -4729,7 +4729,7 @@
           <p:cNvPr id="12" name="">
             <a:extLst xmlns:a="http://schemas.openxmlformats.org/drawingml/2006/main">
               <a:ext uri="{FF2B5EF4-FFF2-40B4-BE49-F238E27FC236}">
-                <a16:creationId xmlns:a16="http://schemas.microsoft.com/office/drawing/2014/main" id="{5957B343-584E-4369-BDF3-4F7700109CC9}"/>
+                <a16:creationId xmlns:a16="http://schemas.microsoft.com/office/drawing/2014/main" id="{C1082ED5-A617-4DA4-8559-77FA27E91E68}"/>
               </a:ext>
             </a:extLst>
           </p:cNvPr>
@@ -4786,7 +4786,7 @@
           <p:cNvPr id="13" name="">
             <a:extLst xmlns:a="http://schemas.openxmlformats.org/drawingml/2006/main">
               <a:ext uri="{FF2B5EF4-FFF2-40B4-BE49-F238E27FC236}">
-                <a16:creationId xmlns:a16="http://schemas.microsoft.com/office/drawing/2014/main" id="{27EBB93D-E8AD-498D-BB04-18E5F57B9F9F}"/>
+                <a16:creationId xmlns:a16="http://schemas.microsoft.com/office/drawing/2014/main" id="{CDF70814-63BD-4600-8887-FED7DF9E095E}"/>
               </a:ext>
             </a:extLst>
           </p:cNvPr>
@@ -4843,7 +4843,7 @@
           <p:cNvPr id="14" name="">
             <a:extLst xmlns:a="http://schemas.openxmlformats.org/drawingml/2006/main">
               <a:ext uri="{FF2B5EF4-FFF2-40B4-BE49-F238E27FC236}">
-                <a16:creationId xmlns:a16="http://schemas.microsoft.com/office/drawing/2014/main" id="{8ABDF6BE-8F87-4CAC-8F03-86444218CB34}"/>
+                <a16:creationId xmlns:a16="http://schemas.microsoft.com/office/drawing/2014/main" id="{841FAFFD-2A87-427C-A24D-8FF51F66A162}"/>
               </a:ext>
             </a:extLst>
           </p:cNvPr>
@@ -4898,7 +4898,7 @@
     </p:spTree>
     <p:extLst>
       <p:ext uri="{BB962C8B-B14F-4D97-AF65-F5344CB8AC3E}">
-        <p14:creationId xmlns:p14="http://schemas.microsoft.com/office/powerpoint/2010/main" val="1490076371"/>
+        <p14:creationId xmlns:p14="http://schemas.microsoft.com/office/powerpoint/2010/main" val="2046335733"/>
       </p:ext>
     </p:extLst>
   </p:cSld>
@@ -4929,7 +4929,7 @@
           <p:cNvPr id="18" name="">
             <a:extLst xmlns:a="http://schemas.openxmlformats.org/drawingml/2006/main">
               <a:ext uri="{FF2B5EF4-FFF2-40B4-BE49-F238E27FC236}">
-                <a16:creationId xmlns:a16="http://schemas.microsoft.com/office/drawing/2014/main" id="{FD8AF954-9553-43C9-9740-BF51C27A7390}"/>
+                <a16:creationId xmlns:a16="http://schemas.microsoft.com/office/drawing/2014/main" id="{605768EE-3FE0-4394-8980-5F3AA697E5CF}"/>
               </a:ext>
             </a:extLst>
           </p:cNvPr>
@@ -4986,7 +4986,7 @@
           <p:cNvPr id="2" name="">
             <a:extLst xmlns:a="http://schemas.openxmlformats.org/drawingml/2006/main">
               <a:ext uri="{FF2B5EF4-FFF2-40B4-BE49-F238E27FC236}">
-                <a16:creationId xmlns:a16="http://schemas.microsoft.com/office/drawing/2014/main" id="{24B7ADCD-32DD-4522-A9C4-6CB32C418DEA}"/>
+                <a16:creationId xmlns:a16="http://schemas.microsoft.com/office/drawing/2014/main" id="{A4E00FD6-ECC1-4D9C-96E5-0131DD623CA3}"/>
               </a:ext>
             </a:extLst>
           </p:cNvPr>
@@ -5043,7 +5043,7 @@
           <p:cNvPr id="3" name="">
             <a:extLst xmlns:a="http://schemas.openxmlformats.org/drawingml/2006/main">
               <a:ext uri="{FF2B5EF4-FFF2-40B4-BE49-F238E27FC236}">
-                <a16:creationId xmlns:a16="http://schemas.microsoft.com/office/drawing/2014/main" id="{B0B20199-4799-4B20-8F66-4D06E6D03ACE}"/>
+                <a16:creationId xmlns:a16="http://schemas.microsoft.com/office/drawing/2014/main" id="{241D1D16-8B27-4ADC-B2A4-EFC4FE202EC6}"/>
               </a:ext>
             </a:extLst>
           </p:cNvPr>
@@ -5073,7 +5073,7 @@
           <p:cNvPr id="4" name="">
             <a:extLst xmlns:a="http://schemas.openxmlformats.org/drawingml/2006/main">
               <a:ext uri="{FF2B5EF4-FFF2-40B4-BE49-F238E27FC236}">
-                <a16:creationId xmlns:a16="http://schemas.microsoft.com/office/drawing/2014/main" id="{40610135-0FC8-456A-8267-A569430AC14A}"/>
+                <a16:creationId xmlns:a16="http://schemas.microsoft.com/office/drawing/2014/main" id="{23D61CFA-1C04-4B07-8882-0DA08DB46F43}"/>
               </a:ext>
             </a:extLst>
           </p:cNvPr>
@@ -5130,7 +5130,7 @@
           <p:cNvPr id="5" name="">
             <a:extLst xmlns:a="http://schemas.openxmlformats.org/drawingml/2006/main">
               <a:ext uri="{FF2B5EF4-FFF2-40B4-BE49-F238E27FC236}">
-                <a16:creationId xmlns:a16="http://schemas.microsoft.com/office/drawing/2014/main" id="{5D3051A9-E604-4B5E-B487-65DF2620575A}"/>
+                <a16:creationId xmlns:a16="http://schemas.microsoft.com/office/drawing/2014/main" id="{3FCF9504-7644-4562-BEB2-4DB15753A772}"/>
               </a:ext>
             </a:extLst>
           </p:cNvPr>
@@ -5187,7 +5187,7 @@
           <p:cNvPr id="6" name="">
             <a:extLst xmlns:a="http://schemas.openxmlformats.org/drawingml/2006/main">
               <a:ext uri="{FF2B5EF4-FFF2-40B4-BE49-F238E27FC236}">
-                <a16:creationId xmlns:a16="http://schemas.microsoft.com/office/drawing/2014/main" id="{08CF3375-A127-4652-AC80-66A8A6BD5B32}"/>
+                <a16:creationId xmlns:a16="http://schemas.microsoft.com/office/drawing/2014/main" id="{68F59105-5909-46B6-9C10-F64A33E3275D}"/>
               </a:ext>
             </a:extLst>
           </p:cNvPr>
@@ -5217,7 +5217,7 @@
           <p:cNvPr id="7" name="">
             <a:extLst xmlns:a="http://schemas.openxmlformats.org/drawingml/2006/main">
               <a:ext uri="{FF2B5EF4-FFF2-40B4-BE49-F238E27FC236}">
-                <a16:creationId xmlns:a16="http://schemas.microsoft.com/office/drawing/2014/main" id="{E5640F17-57A3-41E5-A657-E465E324DE04}"/>
+                <a16:creationId xmlns:a16="http://schemas.microsoft.com/office/drawing/2014/main" id="{E05C2230-9C27-4955-B5A5-3B6F173BA757}"/>
               </a:ext>
             </a:extLst>
           </p:cNvPr>
@@ -5264,7 +5264,7 @@
                 <a:ea typeface="Arial"/>
                 <a:cs typeface="Arial"/>
               </a:rPr>
-              <a:t>A short form creates</a:t>
+              <a:t>A short form and relay</a:t>
             </a:r>
           </a:p>
           <a:p xmlns:a="http://schemas.openxmlformats.org/drawingml/2006/main">
@@ -5287,7 +5287,7 @@
                 <a:ea typeface="Arial"/>
                 <a:cs typeface="Arial"/>
               </a:rPr>
-              <a:t>a structured request.</a:t>
+              <a:t>code carry key facts.</a:t>
             </a:r>
           </a:p>
         </p:txBody>
@@ -5297,7 +5297,7 @@
           <p:cNvPr id="8" name="">
             <a:extLst xmlns:a="http://schemas.openxmlformats.org/drawingml/2006/main">
               <a:ext uri="{FF2B5EF4-FFF2-40B4-BE49-F238E27FC236}">
-                <a16:creationId xmlns:a16="http://schemas.microsoft.com/office/drawing/2014/main" id="{C7E03F9E-784F-41C7-A658-2579F8581D3F}"/>
+                <a16:creationId xmlns:a16="http://schemas.microsoft.com/office/drawing/2014/main" id="{6A83763E-7606-49D9-850D-8CC2FFDD803D}"/>
               </a:ext>
             </a:extLst>
           </p:cNvPr>
@@ -5354,7 +5354,7 @@
           <p:cNvPr id="9" name="">
             <a:extLst xmlns:a="http://schemas.openxmlformats.org/drawingml/2006/main">
               <a:ext uri="{FF2B5EF4-FFF2-40B4-BE49-F238E27FC236}">
-                <a16:creationId xmlns:a16="http://schemas.microsoft.com/office/drawing/2014/main" id="{369E2308-0EA7-4420-A890-6722553AD862}"/>
+                <a16:creationId xmlns:a16="http://schemas.microsoft.com/office/drawing/2014/main" id="{09E9945B-902C-4C11-89AE-CB4588F5B95B}"/>
               </a:ext>
             </a:extLst>
           </p:cNvPr>
@@ -5384,7 +5384,7 @@
           <p:cNvPr id="10" name="">
             <a:extLst xmlns:a="http://schemas.openxmlformats.org/drawingml/2006/main">
               <a:ext uri="{FF2B5EF4-FFF2-40B4-BE49-F238E27FC236}">
-                <a16:creationId xmlns:a16="http://schemas.microsoft.com/office/drawing/2014/main" id="{EBBC8DB4-BF14-4F34-9D35-33097743B10D}"/>
+                <a16:creationId xmlns:a16="http://schemas.microsoft.com/office/drawing/2014/main" id="{720EEAA0-DDFD-4C25-9340-BAFC09BA74F1}"/>
               </a:ext>
             </a:extLst>
           </p:cNvPr>
@@ -5464,7 +5464,7 @@
           <p:cNvPr id="11" name="">
             <a:extLst xmlns:a="http://schemas.openxmlformats.org/drawingml/2006/main">
               <a:ext uri="{FF2B5EF4-FFF2-40B4-BE49-F238E27FC236}">
-                <a16:creationId xmlns:a16="http://schemas.microsoft.com/office/drawing/2014/main" id="{186F826D-C33A-463C-B623-EDF7378A1007}"/>
+                <a16:creationId xmlns:a16="http://schemas.microsoft.com/office/drawing/2014/main" id="{2ED1D6D1-EE7A-4CA2-B656-80C37B28F74B}"/>
               </a:ext>
             </a:extLst>
           </p:cNvPr>
@@ -5521,7 +5521,7 @@
           <p:cNvPr id="12" name="">
             <a:extLst xmlns:a="http://schemas.openxmlformats.org/drawingml/2006/main">
               <a:ext uri="{FF2B5EF4-FFF2-40B4-BE49-F238E27FC236}">
-                <a16:creationId xmlns:a16="http://schemas.microsoft.com/office/drawing/2014/main" id="{DF9B21EA-6724-40D5-A18C-E3E46DE7C8A7}"/>
+                <a16:creationId xmlns:a16="http://schemas.microsoft.com/office/drawing/2014/main" id="{22702EEE-D658-4EE8-8497-41B69C286EBA}"/>
               </a:ext>
             </a:extLst>
           </p:cNvPr>
@@ -5551,7 +5551,7 @@
           <p:cNvPr id="13" name="">
             <a:extLst xmlns:a="http://schemas.openxmlformats.org/drawingml/2006/main">
               <a:ext uri="{FF2B5EF4-FFF2-40B4-BE49-F238E27FC236}">
-                <a16:creationId xmlns:a16="http://schemas.microsoft.com/office/drawing/2014/main" id="{22319C16-6126-4F32-BD9C-F5328070FACB}"/>
+                <a16:creationId xmlns:a16="http://schemas.microsoft.com/office/drawing/2014/main" id="{51D67264-5618-49F3-8CB0-772CCACF4B19}"/>
               </a:ext>
             </a:extLst>
           </p:cNvPr>
@@ -5598,7 +5598,7 @@
                 <a:ea typeface="Arial"/>
                 <a:cs typeface="Arial"/>
               </a:rPr>
-              <a:t>Resource matches consider</a:t>
+              <a:t>Reservations protect</a:t>
             </a:r>
           </a:p>
           <a:p xmlns:a="http://schemas.openxmlformats.org/drawingml/2006/main">
@@ -5621,7 +5621,7 @@
                 <a:ea typeface="Arial"/>
                 <a:cs typeface="Arial"/>
               </a:rPr>
-              <a:t>access barriers.</a:t>
+              <a:t>scarce specialist support.</a:t>
             </a:r>
           </a:p>
         </p:txBody>
@@ -5631,7 +5631,7 @@
           <p:cNvPr id="14" name="">
             <a:extLst xmlns:a="http://schemas.openxmlformats.org/drawingml/2006/main">
               <a:ext uri="{FF2B5EF4-FFF2-40B4-BE49-F238E27FC236}">
-                <a16:creationId xmlns:a16="http://schemas.microsoft.com/office/drawing/2014/main" id="{C851246F-C461-45EA-873F-6906F397ADE0}"/>
+                <a16:creationId xmlns:a16="http://schemas.microsoft.com/office/drawing/2014/main" id="{A9BE0B10-BF82-4C2B-BDF1-AEFB766CD0E6}"/>
               </a:ext>
             </a:extLst>
           </p:cNvPr>
@@ -5661,7 +5661,7 @@
           <p:cNvPr id="15" name="">
             <a:extLst xmlns:a="http://schemas.openxmlformats.org/drawingml/2006/main">
               <a:ext uri="{FF2B5EF4-FFF2-40B4-BE49-F238E27FC236}">
-                <a16:creationId xmlns:a16="http://schemas.microsoft.com/office/drawing/2014/main" id="{2D1ACA1D-D844-4F68-B1F0-A1DEE61C31D1}"/>
+                <a16:creationId xmlns:a16="http://schemas.microsoft.com/office/drawing/2014/main" id="{ACC64A6E-EAA1-4B83-B31A-B1876CB22CD8}"/>
               </a:ext>
             </a:extLst>
           </p:cNvPr>
@@ -5718,7 +5718,7 @@
           <p:cNvPr id="16" name="">
             <a:extLst xmlns:a="http://schemas.openxmlformats.org/drawingml/2006/main">
               <a:ext uri="{FF2B5EF4-FFF2-40B4-BE49-F238E27FC236}">
-                <a16:creationId xmlns:a16="http://schemas.microsoft.com/office/drawing/2014/main" id="{563D62BF-8ACA-43A3-9F5D-C0EB46CBFC5A}"/>
+                <a16:creationId xmlns:a16="http://schemas.microsoft.com/office/drawing/2014/main" id="{CA429414-D891-4647-8425-1B7913458E16}"/>
               </a:ext>
             </a:extLst>
           </p:cNvPr>
@@ -5775,7 +5775,7 @@
           <p:cNvPr id="17" name="">
             <a:extLst xmlns:a="http://schemas.openxmlformats.org/drawingml/2006/main">
               <a:ext uri="{FF2B5EF4-FFF2-40B4-BE49-F238E27FC236}">
-                <a16:creationId xmlns:a16="http://schemas.microsoft.com/office/drawing/2014/main" id="{ECE9752D-4DB9-44C5-919B-9D3BE0FCF809}"/>
+                <a16:creationId xmlns:a16="http://schemas.microsoft.com/office/drawing/2014/main" id="{3037A10B-A42B-4B32-9964-235BDB8FD76D}"/>
               </a:ext>
             </a:extLst>
           </p:cNvPr>
@@ -5830,7 +5830,7 @@
     </p:spTree>
     <p:extLst>
       <p:ext uri="{BB962C8B-B14F-4D97-AF65-F5344CB8AC3E}">
-        <p14:creationId xmlns:p14="http://schemas.microsoft.com/office/powerpoint/2010/main" val="714878918"/>
+        <p14:creationId xmlns:p14="http://schemas.microsoft.com/office/powerpoint/2010/main" val="355738259"/>
       </p:ext>
     </p:extLst>
   </p:cSld>

</xml_diff>